<commit_message>
copied the webots project from mas518 over to this project since they are similar
</commit_message>
<xml_diff>
--- a/Assignment 1/MAS512_assignment1_gr5.pptx
+++ b/Assignment 1/MAS512_assignment1_gr5.pptx
@@ -6349,7 +6349,7 @@
                     <a:p>
                       <a:pPr algn="ctr"/>
                       <a:r>
-                        <a:rPr sz="1100" b="1" i="0">
+                        <a:rPr sz="1100" b="1" i="0" dirty="0">
                           <a:solidFill>
                             <a:srgbClr val="FFFFFF"/>
                           </a:solidFill>
@@ -6357,7 +6357,51 @@
                           <a:ea typeface="Calibri"/>
                           <a:cs typeface="Calibri"/>
                         </a:rPr>
-                        <a:t>Inference [ms/img]</a:t>
+                        <a:t>Inference [</a:t>
+                      </a:r>
+                      <a:r>
+                        <a:rPr sz="1100" b="1" i="0" dirty="0" err="1">
+                          <a:solidFill>
+                            <a:srgbClr val="FFFFFF"/>
+                          </a:solidFill>
+                          <a:latin typeface="Calibri"/>
+                          <a:ea typeface="Calibri"/>
+                          <a:cs typeface="Calibri"/>
+                        </a:rPr>
+                        <a:t>ms</a:t>
+                      </a:r>
+                      <a:r>
+                        <a:rPr sz="1100" b="1" i="0" dirty="0">
+                          <a:solidFill>
+                            <a:srgbClr val="FFFFFF"/>
+                          </a:solidFill>
+                          <a:latin typeface="Calibri"/>
+                          <a:ea typeface="Calibri"/>
+                          <a:cs typeface="Calibri"/>
+                        </a:rPr>
+                        <a:t>/</a:t>
+                      </a:r>
+                      <a:r>
+                        <a:rPr sz="1100" b="1" i="0" dirty="0" err="1">
+                          <a:solidFill>
+                            <a:srgbClr val="FFFFFF"/>
+                          </a:solidFill>
+                          <a:latin typeface="Calibri"/>
+                          <a:ea typeface="Calibri"/>
+                          <a:cs typeface="Calibri"/>
+                        </a:rPr>
+                        <a:t>img</a:t>
+                      </a:r>
+                      <a:r>
+                        <a:rPr sz="1100" b="1" i="0" dirty="0">
+                          <a:solidFill>
+                            <a:srgbClr val="FFFFFF"/>
+                          </a:solidFill>
+                          <a:latin typeface="Calibri"/>
+                          <a:ea typeface="Calibri"/>
+                          <a:cs typeface="Calibri"/>
+                        </a:rPr>
+                        <a:t>]</a:t>
                       </a:r>
                     </a:p>
                   </a:txBody>
@@ -10990,45 +11034,6 @@
           </a:prstGeom>
         </p:spPr>
       </p:pic>
-      <p:sp>
-        <p:nvSpPr>
-          <p:cNvPr id="10" name="TextBox 9"/>
-          <p:cNvSpPr txBox="1"/>
-          <p:nvPr/>
-        </p:nvSpPr>
-        <p:spPr>
-          <a:xfrm>
-            <a:off x="457200" y="4754880"/>
-            <a:ext cx="8229600" cy="274320"/>
-          </a:xfrm>
-          <a:prstGeom prst="rect">
-            <a:avLst/>
-          </a:prstGeom>
-          <a:noFill/>
-        </p:spPr>
-        <p:txBody>
-          <a:bodyPr wrap="square" lIns="0" tIns="0" rIns="0" bIns="0" anchor="ctr">
-            <a:spAutoFit/>
-          </a:bodyPr>
-          <a:lstStyle/>
-          <a:p>
-            <a:pPr marL="0" indent="0" algn="l">
-              <a:buNone/>
-            </a:pPr>
-            <a:r>
-              <a:rPr sz="900" b="0" i="0">
-                <a:solidFill>
-                  <a:srgbClr val="7C8494"/>
-                </a:solidFill>
-                <a:latin typeface="Calibri"/>
-                <a:ea typeface="Calibri"/>
-                <a:cs typeface="Calibri"/>
-              </a:rPr>
-              <a:t>Q6 · Train and val loss overlap → no overfitting.</a:t>
-            </a:r>
-          </a:p>
-        </p:txBody>
-      </p:sp>
     </p:spTree>
   </p:cSld>
   <p:clrMapOvr>
@@ -11554,98 +11559,6 @@
           </a:p>
         </p:txBody>
       </p:sp>
-      <p:sp>
-        <p:nvSpPr>
-          <p:cNvPr id="13" name="TextBox 12"/>
-          <p:cNvSpPr txBox="1"/>
-          <p:nvPr/>
-        </p:nvSpPr>
-        <p:spPr>
-          <a:xfrm>
-            <a:off x="4132332" y="4289929"/>
-            <a:ext cx="5166360" cy="184666"/>
-          </a:xfrm>
-          <a:prstGeom prst="rect">
-            <a:avLst/>
-          </a:prstGeom>
-          <a:noFill/>
-        </p:spPr>
-        <p:txBody>
-          <a:bodyPr wrap="square" lIns="0" tIns="0" rIns="0" bIns="0" anchor="t">
-            <a:spAutoFit/>
-          </a:bodyPr>
-          <a:lstStyle/>
-          <a:p>
-            <a:pPr>
-              <a:spcAft>
-                <a:spcPts val="480"/>
-              </a:spcAft>
-              <a:buSzPct val="100000"/>
-            </a:pPr>
-            <a:r>
-              <a:rPr lang="en-US" sz="1200" b="0" i="0" dirty="0">
-                <a:solidFill>
-                  <a:srgbClr val="23262F"/>
-                </a:solidFill>
-                <a:latin typeface="Calibri"/>
-                <a:ea typeface="Calibri"/>
-                <a:cs typeface="Calibri"/>
-              </a:rPr>
-              <a:t>Healthy motor </a:t>
-            </a:r>
-            <a:r>
-              <a:rPr sz="1200" b="0" i="0" dirty="0">
-                <a:solidFill>
-                  <a:srgbClr val="23262F"/>
-                </a:solidFill>
-                <a:latin typeface="Calibri"/>
-                <a:ea typeface="Calibri"/>
-                <a:cs typeface="Calibri"/>
-              </a:rPr>
-              <a:t>is reconstructed best</a:t>
-            </a:r>
-          </a:p>
-        </p:txBody>
-      </p:sp>
-      <p:sp>
-        <p:nvSpPr>
-          <p:cNvPr id="14" name="TextBox 13"/>
-          <p:cNvSpPr txBox="1"/>
-          <p:nvPr/>
-        </p:nvSpPr>
-        <p:spPr>
-          <a:xfrm>
-            <a:off x="457200" y="4754880"/>
-            <a:ext cx="8229600" cy="274320"/>
-          </a:xfrm>
-          <a:prstGeom prst="rect">
-            <a:avLst/>
-          </a:prstGeom>
-          <a:noFill/>
-        </p:spPr>
-        <p:txBody>
-          <a:bodyPr wrap="square" lIns="0" tIns="0" rIns="0" bIns="0" anchor="ctr">
-            <a:spAutoFit/>
-          </a:bodyPr>
-          <a:lstStyle/>
-          <a:p>
-            <a:pPr marL="0" indent="0" algn="l">
-              <a:buNone/>
-            </a:pPr>
-            <a:r>
-              <a:rPr sz="900" b="0" i="0">
-                <a:solidFill>
-                  <a:srgbClr val="7C8494"/>
-                </a:solidFill>
-                <a:latin typeface="Calibri"/>
-                <a:ea typeface="Calibri"/>
-                <a:cs typeface="Calibri"/>
-              </a:rPr>
-              <a:t>Q6 · Latent colour scale is shared within each figure.</a:t>
-            </a:r>
-          </a:p>
-        </p:txBody>
-      </p:sp>
     </p:spTree>
   </p:cSld>
   <p:clrMapOvr>
@@ -12119,8 +12032,8 @@
           </a:p>
         </p:txBody>
       </p:sp>
-      <mc:AlternateContent xmlns:mc="http://schemas.openxmlformats.org/markup-compatibility/2006">
-        <mc:Choice xmlns:a14="http://schemas.microsoft.com/office/drawing/2010/main" Requires="a14">
+      <mc:AlternateContent xmlns:mc="http://schemas.openxmlformats.org/markup-compatibility/2006" xmlns:a14="http://schemas.microsoft.com/office/drawing/2010/main">
+        <mc:Choice Requires="a14">
           <p:sp>
             <p:nvSpPr>
               <p:cNvPr id="14" name="Text 12"/>
@@ -12187,7 +12100,7 @@
             </p:txBody>
           </p:sp>
         </mc:Choice>
-        <mc:Fallback>
+        <mc:Fallback xmlns="">
           <p:sp>
             <p:nvSpPr>
               <p:cNvPr id="14" name="Text 12"/>
@@ -12441,7 +12354,7 @@
                 <a:ea typeface="Calibri" pitchFamily="34" charset="-122"/>
                 <a:cs typeface="Calibri" pitchFamily="34" charset="-120"/>
               </a:rPr>
-              <a:t>Autoencoder: 10 500 → 32 values, mean MSE ≈ 0.0005 for both classes</a:t>
+              <a:t>mean MSE ≈ 0.0005 for both classes</a:t>
             </a:r>
             <a:endParaRPr lang="en-US" sz="1300" dirty="0"/>
           </a:p>

</xml_diff>